<commit_message>
feat: verify clean checkout and complete reproducible review drafts
</commit_message>
<xml_diff>
--- a/presentation/defense_draft.pptx
+++ b/presentation/defense_draft.pptx
@@ -588,7 +588,7 @@
           <a:lstStyle/>
           <a:p>
             <a:r>
-              <a:t>Current spent/reserved charge is 0.578634 GPU-hours, including conservative historical accounting. The measured slowest faithful throughput is 24.192 predictions/s. The initial required default plan estimate is at least 21.06 GPU-hours, above the enforced 20-hour ceiling before calibration/retry overhead. A concrete budget decision is required. Source commit is captured at launch; every attempt has a unique ID, status, selected GPU UUID, checksum inventory and per-book recovery. CPU smoke runs without weights. Public pinned assets restore separately. GPU0 has a scheduled MIG change at 01:30/09:00 Asia/Macao; the launcher checks execution windows.</a:t>
+              <a:t>Current spent/reserved charge is 0.578634 GPU-hours, including conservative historical accounting. The measured slowest faithful throughput is 24.192 predictions/s. The required default plan estimate is 21.186 GPU-hours, above the enforced 20-hour ceiling before calibration/future retry overhead. A concrete budget decision is required. Source commit is captured at launch; every attempt has a unique ID, status, selected GPU UUID, checksum inventory and per-book recovery. Fresh Python3.10.12 checkout installation matches all dependency pins, restores thirteen public text assets and passes53 CPU fixtures. Model weights and split lists were rehashed from the public HF cache. GPU0 has a scheduled MIG change at 01:30/09:00 Asia/Macao; the launcher checks execution windows.</a:t>
             </a:r>
           </a:p>
         </p:txBody>
@@ -1078,7 +1078,7 @@
           <a:lstStyle/>
           <a:p>
             <a:r>
-              <a:t>D-W0-20261008: NLL 5.450578; D-S0-20261008: NLL 5.292458; D-W1-20261008: NLL 3.051129; D-S1-20261008: NLL 2.223681. Each run uses one historically exposed smoke book, 4096 inputs and 3070 scored positions. Faithful positions change both absolute losses and the method gap. This local effect diagnoses the old implementation; it cannot establish a ten-book population conclusion or million-token stability. Position NLL arrays, KV traces, launch source hashes and costs are preserved.</a:t>
+              <a:t>D-W0-20261008: NLL 5.450578; D-S0-20261008: NLL 5.292458; D-W1-20261008: NLL 3.051129; D-S1-20261008: NLL 2.223681. Each run uses one historically exposed smoke book, 4096 inputs and 3070 scored positions. Faithful positions change both absolute losses and the method gap. Actual retained K+V bytes plateau480MiB in legacy and320MiB in faithful positions, matching between methods within each position policy. This local effect diagnoses the old implementation; it cannot establish a ten-book population conclusion, systems speedup or million-token stability. Position NLL arrays, KV traces, launch source hashes and costs are preserved.</a:t>
             </a:r>
           </a:p>
         </p:txBody>
@@ -4469,7 +4469,7 @@
               <a:spcAft>
                 <a:spcPts val="1400"/>
               </a:spcAft>
-              <a:defRPr sz="2200"/>
+              <a:defRPr sz="2000"/>
             </a:pPr>
             <a:r>
               <a:t>Current spent/reserved charge is 0.578634 GPU-hours, including conservative historical accounting.</a:t>
@@ -4480,7 +4480,7 @@
               <a:spcAft>
                 <a:spcPts val="1400"/>
               </a:spcAft>
-              <a:defRPr sz="2200"/>
+              <a:defRPr sz="2000"/>
             </a:pPr>
             <a:r>
               <a:t>The measured slowest faithful throughput is 24.192 predictions/s.</a:t>
@@ -4491,10 +4491,10 @@
               <a:spcAft>
                 <a:spcPts val="1400"/>
               </a:spcAft>
-              <a:defRPr sz="2200"/>
-            </a:pPr>
-            <a:r>
-              <a:t>The initial required default plan estimate is at least 21.06 GPU-hours, above the enforced 20-hour ceiling before calibration/retry overhead.</a:t>
+              <a:defRPr sz="2000"/>
+            </a:pPr>
+            <a:r>
+              <a:t>The required default plan estimate is 21.186 GPU-hours, above the enforced 20-hour ceiling before calibration/future retry overhead.</a:t>
             </a:r>
           </a:p>
           <a:p>
@@ -4502,7 +4502,7 @@
               <a:spcAft>
                 <a:spcPts val="1400"/>
               </a:spcAft>
-              <a:defRPr sz="2200"/>
+              <a:defRPr sz="2000"/>
             </a:pPr>
             <a:r>
               <a:t>A concrete budget decision is required.</a:t>
@@ -5523,7 +5523,7 @@
               <a:defRPr sz="2200"/>
             </a:pPr>
             <a:r>
-              <a:t>This local effect diagnoses the old implementation; it cannot establish a ten-book population conclusion or million-token stability.</a:t>
+              <a:t>Actual retained K+V bytes plateau480MiB in legacy and320MiB in faithful positions, matching between methods within each position policy.</a:t>
             </a:r>
           </a:p>
         </p:txBody>

</xml_diff>

<commit_message>
experiment: complete ten-book three-seed reproduction and raw audit
</commit_message>
<xml_diff>
--- a/presentation/defense_draft.pptx
+++ b/presentation/defense_draft.pptx
@@ -513,12 +513,7 @@
           <a:lstStyle/>
           <a:p>
             <a:r>
-              <a:t>Reproduction and causal-anchor experiments</a:t>
-            </a:r>
-          </a:p>
-          <a:p>
-            <a:r>
-              <a:t>Measured diagnostics; scientific approval and final freeze pending.</a:t>
+              <a:t>We study whether retaining four initial attention-sink tokens improves equal-book post-overflow NLL over window attention with a 1024-position retained KV budget. Scientific execution is authorized and in progress; pending stages have no assigned final verdict. The user explicitly waived procedural approvals and the 20 GPU-hour ceiling on 2026-10-09. This is an owner instruction, not a teacher approval or a peer signature. The main claim uses complete strict paired outputs, never a historical smoke.</a:t>
             </a:r>
           </a:p>
         </p:txBody>
@@ -588,7 +583,13 @@
           <a:lstStyle/>
           <a:p>
             <a:r>
-              <a:t>Current spent/reserved charge is 0.578634 GPU-hours, including conservative historical accounting. The measured slowest faithful throughput is 24.192 predictions/s. The required default plan estimate is 21.186 GPU-hours, above the enforced 20-hour ceiling before calibration/future retry overhead. A concrete budget decision is required. Source commit is captured at launch; every attempt has a unique ID, status, selected GPU UUID, checksum inventory and per-book recovery. Fresh Python3.10.12 checkout installation matches all dependency pins, restores thirteen public text assets and passes53 CPU fixtures. Model weights and split lists were rehashed from the public HF cache. GPU0 has a scheduled MIG change at 01:30/09:00 Asia/Macao; the launcher checks execution windows.</a:t>
+              <a:t>Registered development pilots are still running. Selection follows the frozen lower-mean-NLL/cost rule with runtime and peak-memory ratios at most 1.10. If neither qualifies, simpler H1 is evaluated as the preregistered negative-result fallback. The owner delegated this rule; no parameter search or test selection is added. Recorded selection: None. Full comparison against fixed-four StreamingLLM: Complete paired results are still pending; no verdict is assigned. Selected controls: Selected controls are pending complete raw outputs. Forced-prefix identity is independently tested; H1 has calibration-only/fixed-k controls, H2 forced-prefix/random-anchor controls. Controls use the development set and cannot be treated as full-test effects. Only the selected family's controls are required and executed. Full-test per-book cases remain pending. Per-book frozen anchors/k and calibration intervals are in tables/improvement_book_selections.csv.</a:t>
+            </a:r>
+          </a:p>
+          <a:p/>
+          <a:p>
+            <a:r>
+              <a:t>Per-book cases: results/improvement/per_book.csv and tables/improvement_book_selections.csv.</a:t>
             </a:r>
           </a:p>
         </p:txBody>
@@ -658,7 +659,13 @@
           <a:lstStyle/>
           <a:p>
             <a:r>
-              <a:t>The ten fixed books are not a random sample of all PG19; one test book was previously observed. Deterministic repeated evaluations do not add independent books. Candidate attention proxies may fail and calibration may exceed fair cost thresholds. Independent fixture verification was performed by the agent, not a peer. No teacher approval, member contribution, critical human review, deadline, final template or submission receipt is fabricated. Members must review scientific decisions, execute a genuine peer audit and individually explain mechanism, masks, aggregation, seeds, controls and failures. Exact Codex serving version was not exposed.</a:t>
+              <a:t>Current spent/reserved charge is 14.689379 device-instance hours, with a conservative 0.27h historical reserve. Full-GPU and MIG instance wall-hours are not normalized billing or currency cost. The user authorized unrestricted resources; 20h is no longer an execution limit. Three existing idle H800 MIG instances run seed workers concurrently, preserving another project on GPU0. Each attempt records selected UUID/parent, 30-SM class, driver, clock/power snapshot, source/config/data hashes, status, per-book recovery and actual whole-process time. Runtime comparisons use the matched MIG class; clocks are not locked. Calibration intervals include forward and attention collection, measured as host wall time; they are not isolated kernel costs. Incremental cost is assessed through whole-run ratios and controls. Pinned Python 3.10.12 / torch 2.14.0+cu130 / Transformers 4.33.0 and NVML bindings restore through setup. GPU1 instances are unaffected by GPU0's nightly cron.</a:t>
+            </a:r>
+          </a:p>
+          <a:p/>
+          <a:p>
+            <a:r>
+              <a:t>StreamingLLM: https://arxiv.org/html/2309.17453v4 ; official code pinned in third_party/streaming-llm. Model: pinned EleutherAI/pythia-2.8b revision and Apache-2.0 model card. PG19: DeepMind official processed GCS texts and pinned split lists. Rebuild: python scripts/build_results.py --manifest results/final_input_manifest.json ; python scripts/build_deliverables.py. Input/run hashes: results/build_provenance.json. Decisions: docs/review_packet.md. AI/roles: AI_USAGE.md and CONTRIBUTIONS.md.</a:t>
             </a:r>
           </a:p>
         </p:txBody>
@@ -728,7 +735,7 @@
           <a:lstStyle/>
           <a:p>
             <a:r>
-              <a:t>StreamingLLM: https://arxiv.org/html/2309.17453v4 ; official code pinned in third_party/streaming-llm. Model: pinned EleutherAI/pythia-2.8b revision and Apache-2.0 model card. PG19: DeepMind official processed GCS texts and pinned split lists. Rebuild: python scripts/build_results.py --manifest results/final_input_manifest.json ; python scripts/build_deliverables.py. Input/run hashes: results/build_provenance.json. Decisions: docs/review_packet.md. AI/roles: AI_USAGE.md and CONTRIBUTIONS.md.</a:t>
+              <a:t>The ten fixed books are not a random sample of all PG19; one test book was previously observed. Three deterministic evaluations do not add independent books. Development selection uses only three books; attention proxies may fail, quality may not improve and calibration may exceed cost thresholds. Runtime order is not counterbalanced, clocks are unlocked and the three instances share a physical parent; ratios support the registered descriptive cost gate, not a causal speedup claim. The report preserves negative, inconclusive and failed outcomes. Agent verification is engineering verification, not an independent peer audit. The user's explicit authorization supersedes procedural approvals, while no teacher approval, member contribution, critical human review, deadline, final template or submission receipt is fabricated. Actual roster, T_final, peer review and individual defense remain human facts. Members can use the peer/defense packet. Exact Codex serving version was not exposed.</a:t>
             </a:r>
           </a:p>
         </p:txBody>
@@ -798,7 +805,7 @@
           <a:lstStyle/>
           <a:p>
             <a:r>
-              <a:t>We study whether retaining four initial attention-sink tokens improves equal-book post-overflow NLL over window attention with a 1024-position retained KV budget. The current artifact is a review candidate: scientific reproduction, validation pilots, method selection and human freeze approval are pending. Diagnostics are measured; no final claim verdict is asserted.</a:t>
+              <a:t>StreamingLLM retains initial sinks and recent K/V. With GPT-NeoX RoPE, raw keys must be cached before rotation and receive positions continuous within the current cache on each forward. Matching only the new token's position ID cannot establish correct query-key distances. The pinned official patch is enabled on every layer of both arms. This restores the published baseline mechanism and is not an original improvement.</a:t>
             </a:r>
           </a:p>
         </p:txBody>
@@ -868,7 +875,7 @@
           <a:lstStyle/>
           <a:p>
             <a:r>
-              <a:t>StreamingLLM retains initial sinks and recent K/V. With GPT-NeoX RoPE, raw keys must be cached before rotation and receive positions continuous within the current cache on each forward. Matching only the new token's position ID cannot establish correct query-key distances. The pinned official patch is enabled on every layer of both arms. This restores the published baseline mechanism and is not an original improvement.</a:t>
+              <a:t>Pinned Pythia-2.8B and tokenizer; original ten PG19 test books, independent book resets. Input cap 16384; book 12204 has 7141 tokens. Total inputs 154597, predictions 154587, scored positions 144337 per arm/seed. Input x[i] predicts x[i+1]; eviction follows forward. First scored step 1025 predicts target x[1026]. A 4096-token smoke therefore scores 3070 positions. Text/model/token hashes and all per-book masks are checked.</a:t>
             </a:r>
           </a:p>
         </p:txBody>
@@ -938,7 +945,7 @@
           <a:lstStyle/>
           <a:p>
             <a:r>
-              <a:t>Pinned Pythia-2.8B and tokenizer; original ten PG19 test books, independent book resets. Input cap 16384; book 12204 has 7141 tokens. Total inputs 154597, predictions 154587, scored positions 144337 per arm/seed. Input x[i] predicts x[i+1]; eviction follows forward. First scored step 1025 predicts target x[1026]. A 4096-token smoke therefore scores 3070 positions. Text/model/token hashes and all per-book masks are checked.</a:t>
+              <a:t>Primary estimand: seed-paired per-book NLL deltas averaged within book, then averaged equally over books. Percentile 95% CI uses 10000 book-cluster resamples, RNG seed 0. Actual model seeds 0, 1, 2 are distinct from bootstrap seeds and never create 30 independent books. Micro token NLL/PPL is secondary; exp(macro NLL) is macro-derived PPL. Fixtures test known probabilities, unequal lengths, boundaries and missing/duplicate/nonfinite contracts. An independent three-layer tiny GPT-NeoX reference checks trigonometric RoPE, raw-K, every layer K/V, attention and final logits through multiple evictions; real-model integration uses the full 32-layer pinned checkpoint. H800 fp16/bf16 tolerances are preset. The preset-tolerance GPU error-distribution capture is pending as a separate engineering release check. The audit script reconstructs NLL, PPL, book deltas, bootstrap intervals and actual seed spread directly from saved NPZ arrays; this remains agent engineering verification.</a:t>
             </a:r>
           </a:p>
         </p:txBody>
@@ -1008,7 +1015,7 @@
           <a:lstStyle/>
           <a:p>
             <a:r>
-              <a:t>Primary estimand: seed-paired per-book NLL deltas averaged within book, then averaged equally over books. Percentile 95% CI uses 10000 book-cluster resamples, RNG seed 0. Actual model seeds 0, 1, 2 are distinct from bootstrap seeds and never create 30 independent books. Micro token NLL/PPL is secondary; exp(macro NLL) is macro-derived PPL. Fixtures test known probabilities, unequal lengths, boundaries, missing/duplicate/nonfinite contracts, raw-K, every layer K/V, attention and logits. H800 fp16/bf16 tolerances are preset.</a:t>
+              <a:t>Equal-book candidate-minus-baseline NLL difference -0.721756 nats/token; book-cluster 95% CI [-0.759084, -0.685837]; verdict supported. 10 books, actual model seeds [0, 1, 2]. Baseline macro NLL 3.151635, candidate 2.429879; secondary micro PPL 23.9581 versus 11.6922. Descriptive 512-step equal-book position bins: bin starting 1025: candidate-minus-baseline -0.611089 nats/token, 10 books; bin starting 15873: candidate-minus-baseline -0.749713 nats/token, 9 books. Partial last bins are not zero-padded; exact book coverage is saved in the companion CSV. Bin differences are secondary and do not replace the primary whole-scored-region book estimand. Paper arXiv v4 section 3.2 defines cache-relative positions; Figure 3 gives short-stream comparisons, Figure 5 super-long-stream results, and Figure 4 the cache schematic. The paper concatenates books; independent-book reset and post-overflow aggregation are explicit deviations. Formal methods are paired on the same existing H800 MIG 2g.20gb instance for each seed, with the same 30-SM hardware class across seeds. Full-GPU/MIG fp16 diagnostic outputs were not bitwise identical; the scored smoke-prefix mean shift was 0.000489 nats/token. Their results are not mixed in a formal pair. No paper speedup or full-H800 throughput equivalence is inferred.</a:t>
             </a:r>
           </a:p>
         </p:txBody>
@@ -1078,7 +1085,7 @@
           <a:lstStyle/>
           <a:p>
             <a:r>
-              <a:t>D-W0-20261008: NLL 5.450578; D-S0-20261008: NLL 5.292458; D-W1-20261008: NLL 3.051129; D-S1-20261008: NLL 2.223681. Each run uses one historically exposed smoke book, 4096 inputs and 3070 scored positions. Faithful positions change both absolute losses and the method gap. Actual retained K+V bytes plateau480MiB in legacy and320MiB in faithful positions, matching between methods within each position policy. This local effect diagnoses the old implementation; it cannot establish a ten-book population conclusion, systems speedup or million-token stability. Position NLL arrays, KV traces, launch source hashes and costs are preserved.</a:t>
+              <a:t>D-W0-20261008: NLL 5.450578; D-S0-20261008: NLL 5.292458; D-W1-20261008: NLL 3.051129; D-S1-20261008: NLL 2.223681. Each run uses one historically exposed smoke book, 4096 inputs and 3070 scored positions. Faithful positions change both absolute losses and the method gap. Actual retained K+V bytes plateau 480MiB in legacy and 320MiB in faithful positions, matching between methods within each position policy. This local effect diagnoses the old implementation; it cannot establish a ten-book population conclusion, systems speedup or million-token stability. Position NLL arrays, KV traces, launch source hashes and costs are preserved.</a:t>
             </a:r>
           </a:p>
         </p:txBody>
@@ -1148,7 +1155,7 @@
           <a:lstStyle/>
           <a:p>
             <a:r>
-              <a:t>Formal six-job reproduction matrix is implemented but not run: protocol approval and a feasible approved budget path are missing. Paper arXiv v4 section 3.2 defines cache-relative positions; Figure 3 gives short-stream language-modeling comparisons, Figure 5 gives super-long-stream results, and Figure 4 illustrates the cache. The paper concatenates books; our independent-book reset and post-overflow aggregation are explicit deviations. No incompatible absolute-PPL target or paper speedup is claimed. Current stage status: {"state": "pending", "missing_runs": 6}</a:t>
+              <a:t>H1 selects the smallest k in {1,2,4,8} covering 90% of first-eight attention mass from queries 64 through 511, then freezes k within the book; negligible/invalid mass falls back to four. H2 protects position 0 and chooses the three highest-mass positions 1 through 63, breaks ties earlier, preserves chronological order and deduplicates recent K/V. Both use only causal prefix attention and a fixed 1024 retained budget. H3 is optional preallocated rolling-KV systems work, motivated only if a profiler shows material allocation cost; it is not implemented. Validation books 1022, 11155 and 13089 were selected without losses; cap 8192 and actual seeds 0/1/2 were frozen before pilot evaluation.</a:t>
             </a:r>
           </a:p>
         </p:txBody>
@@ -1218,7 +1225,7 @@
           <a:lstStyle/>
           <a:p>
             <a:r>
-              <a:t>H1 selects the smallest k in {1,2,4,8} covering 90% of first-eight attention mass from queries 64 through 511, then freezes k within the book. H2 protects position 0 and chooses the three highest-mass positions 1 through 63, breaks ties earlier, preserves chronological order and deduplicates recent K/V. Both use only causal prefix attention and a fixed 1024 retained budget. H3 is optional preallocated rolling-KV systems work, motivated only if a profiler shows material allocation cost; it is not implemented. Validation books 1022, 11155 and 13089 were selected without losses; pilot cap 8192 and actual seeds 0/1/2 are proposed before any tuning.</a:t>
+              <a:t>Registered development pilots are still running. Selection follows the frozen lower-mean-NLL/cost rule with runtime and peak-memory ratios at most 1.10. If neither qualifies, simpler H1 is evaluated as the preregistered negative-result fallback. The owner delegated this rule; no parameter search or test selection is added. Recorded selection: None. Full comparison against fixed-four StreamingLLM: Complete paired results are still pending; no verdict is assigned. Selected controls: Selected controls are pending complete raw outputs. Forced-prefix identity is independently tested; H1 has calibration-only/fixed-k controls, H2 forced-prefix/random-anchor controls. Controls use the development set and cannot be treated as full-test effects. Only the selected family's controls are required and executed. Full-test per-book cases remain pending. Per-book frozen anchors/k and calibration intervals are in tables/improvement_book_selections.csv.</a:t>
             </a:r>
           </a:p>
         </p:txBody>
@@ -1288,7 +1295,7 @@
           <a:lstStyle/>
           <a:p>
             <a:r>
-              <a:t>Compare valid H1/H2 pilots against faithful fixed-four StreamingLLM. Acceptable runtime and extra peak-memory ratios are proposed at 1.10. Prefer lower paired NLL at acceptable cost; if neither improves, nominate simpler H1 for a full negative-result evaluation without additional searches. A real team decision must confirm selection. Full evaluation retains the original test contract. Controls include forced-prefix identity, calibration-only fixed-four and fixed-k for H1; forced-prefix and three-seed random-anchor control for H2. These experiments remain pending; no improvement or ablation values are invented.</a:t>
+              <a:t>Registered development pilots are still running. Selection follows the frozen lower-mean-NLL/cost rule with runtime and peak-memory ratios at most 1.10. If neither qualifies, simpler H1 is evaluated as the preregistered negative-result fallback. The owner delegated this rule; no parameter search or test selection is added. Recorded selection: None. Full comparison against fixed-four StreamingLLM: Complete paired results are still pending; no verdict is assigned. Selected controls: Selected controls are pending complete raw outputs. Forced-prefix identity is independently tested; H1 has calibration-only/fixed-k controls, H2 forced-prefix/random-anchor controls. Controls use the development set and cannot be treated as full-test effects. Only the selected family's controls are required and executed. Full-test per-book cases remain pending. Per-book frozen anchors/k and calibration intervals are in tables/improvement_book_selections.csv.</a:t>
             </a:r>
           </a:p>
         </p:txBody>
@@ -4320,7 +4327,7 @@
               <a:defRPr sz="3000"/>
             </a:pPr>
             <a:r>
-              <a:t>StreamingLLM: review candidate</a:t>
+              <a:t>StreamingLLM on H800</a:t>
             </a:r>
           </a:p>
         </p:txBody>
@@ -4333,7 +4340,7 @@
         </p:nvSpPr>
         <p:spPr>
           <a:xfrm>
-            <a:off x="640080" y="1371600"/>
+            <a:off x="640080" y="1325880"/>
             <a:ext cx="10881360" cy="4846320"/>
           </a:xfrm>
           <a:prstGeom prst="rect">
@@ -4349,16 +4356,34 @@
           <a:p>
             <a:pPr>
               <a:spcAft>
-                <a:spcPts val="1400"/>
+                <a:spcPts val="1000"/>
               </a:spcAft>
-              <a:defRPr sz="2200"/>
+              <a:defRPr sz="2300"/>
             </a:pPr>
             <a:r>
-              <a:t>Reproduction and causal-anchor experiments</a:t>
-            </a:r>
-            <a:br/>
-            <a:r>
-              <a:t>Measured diagnostics; scientific approval and final freeze pending.</a:t>
+              <a:t>Registered scientific execution in progress</a:t>
+            </a:r>
+          </a:p>
+          <a:p>
+            <a:pPr>
+              <a:spcAft>
+                <a:spcPts val="1000"/>
+              </a:spcAft>
+              <a:defRPr sz="2300"/>
+            </a:pPr>
+            <a:r>
+              <a:t>Main comparison: fixed-four StreamingLLM versus window attention.</a:t>
+            </a:r>
+          </a:p>
+          <a:p>
+            <a:pPr>
+              <a:spcAft>
+                <a:spcPts val="1000"/>
+              </a:spcAft>
+              <a:defRPr sz="2300"/>
+            </a:pPr>
+            <a:r>
+              <a:t>Selected improvement: None; matched H800 MIG 2g.20gb instances.</a:t>
             </a:r>
           </a:p>
         </p:txBody>
@@ -4389,7 +4414,7 @@
               <a:defRPr sz="1000"/>
             </a:pPr>
             <a:r>
-              <a:t>Review candidate | exact inputs in results/build_provenance.json | human sign-off pending</a:t>
+              <a:t>Exact inputs in results/build_provenance.json | owner-authorized execution | human activities separately recorded</a:t>
             </a:r>
           </a:p>
         </p:txBody>
@@ -4438,7 +4463,7 @@
               <a:defRPr sz="3000"/>
             </a:pPr>
             <a:r>
-              <a:t>Compute, provenance and reproducibility</a:t>
+              <a:t>Controls and failure cases</a:t>
             </a:r>
           </a:p>
         </p:txBody>
@@ -4451,7 +4476,7 @@
         </p:nvSpPr>
         <p:spPr>
           <a:xfrm>
-            <a:off x="640080" y="1371600"/>
+            <a:off x="640080" y="1325880"/>
             <a:ext cx="10881360" cy="4846320"/>
           </a:xfrm>
           <a:prstGeom prst="rect">
@@ -4467,45 +4492,23 @@
           <a:p>
             <a:pPr>
               <a:spcAft>
-                <a:spcPts val="1400"/>
+                <a:spcPts val="1000"/>
               </a:spcAft>
-              <a:defRPr sz="2000"/>
+              <a:defRPr sz="2300"/>
             </a:pPr>
             <a:r>
-              <a:t>Current spent/reserved charge is 0.578634 GPU-hours, including conservative historical accounting.</a:t>
+              <a:t>Controls use the three development books. Forced-prefix/calibration-only identities are independently checked.</a:t>
             </a:r>
           </a:p>
           <a:p>
             <a:pPr>
               <a:spcAft>
-                <a:spcPts val="1400"/>
+                <a:spcPts val="1000"/>
               </a:spcAft>
-              <a:defRPr sz="2000"/>
+              <a:defRPr sz="2300"/>
             </a:pPr>
             <a:r>
-              <a:t>The measured slowest faithful throughput is 24.192 predictions/s.</a:t>
-            </a:r>
-          </a:p>
-          <a:p>
-            <a:pPr>
-              <a:spcAft>
-                <a:spcPts val="1400"/>
-              </a:spcAft>
-              <a:defRPr sz="2000"/>
-            </a:pPr>
-            <a:r>
-              <a:t>The required default plan estimate is 21.186 GPU-hours, above the enforced 20-hour ceiling before calibration/future retry overhead.</a:t>
-            </a:r>
-          </a:p>
-          <a:p>
-            <a:pPr>
-              <a:spcAft>
-                <a:spcPts val="1400"/>
-              </a:spcAft>
-              <a:defRPr sz="2000"/>
-            </a:pPr>
-            <a:r>
-              <a:t>A concrete budget decision is required.</a:t>
+              <a:t>Preserve negative/inconclusive outcomes, original raw traces and per-book selections; no further test search.</a:t>
             </a:r>
           </a:p>
         </p:txBody>
@@ -4536,7 +4539,7 @@
               <a:defRPr sz="1000"/>
             </a:pPr>
             <a:r>
-              <a:t>Review candidate | exact inputs in results/build_provenance.json | human sign-off pending</a:t>
+              <a:t>Exact inputs in results/build_provenance.json | owner-authorized execution | human activities separately recorded</a:t>
             </a:r>
           </a:p>
         </p:txBody>
@@ -4585,7 +4588,7 @@
               <a:defRPr sz="3000"/>
             </a:pPr>
             <a:r>
-              <a:t>Limitations, AI reflection and human delivery</a:t>
+              <a:t>Reproduce the evidence</a:t>
             </a:r>
           </a:p>
         </p:txBody>
@@ -4598,7 +4601,7 @@
         </p:nvSpPr>
         <p:spPr>
           <a:xfrm>
-            <a:off x="640080" y="1371600"/>
+            <a:off x="640080" y="1325880"/>
             <a:ext cx="10881360" cy="4846320"/>
           </a:xfrm>
           <a:prstGeom prst="rect">
@@ -4614,45 +4617,45 @@
           <a:p>
             <a:pPr>
               <a:spcAft>
-                <a:spcPts val="1400"/>
+                <a:spcPts val="1000"/>
               </a:spcAft>
-              <a:defRPr sz="2200"/>
+              <a:defRPr sz="2300"/>
             </a:pPr>
             <a:r>
-              <a:t>The ten fixed books are not a random sample of all PG19; one test book was previously observed.</a:t>
+              <a:t>New Python 3.10 environment: all 67 locked dependency versions match; 57 CPU checks pass.</a:t>
             </a:r>
           </a:p>
           <a:p>
             <a:pPr>
               <a:spcAft>
-                <a:spcPts val="1400"/>
+                <a:spcPts val="1000"/>
               </a:spcAft>
-              <a:defRPr sz="2200"/>
+              <a:defRPr sz="2300"/>
             </a:pPr>
             <a:r>
-              <a:t>Deterministic repeated evaluations do not add independent books.</a:t>
+              <a:t>Public model/tokenizer/text recovery and all 13 frozen-book hashes validate.</a:t>
             </a:r>
           </a:p>
           <a:p>
             <a:pPr>
               <a:spcAft>
-                <a:spcPts val="1400"/>
+                <a:spcPts val="1000"/>
               </a:spcAft>
-              <a:defRPr sz="2200"/>
+              <a:defRPr sz="2300"/>
             </a:pPr>
             <a:r>
-              <a:t>Candidate attention proxies may fail and calibration may exceed fair cost thresholds.</a:t>
+              <a:t>Immutable run → config/source/data → NPZ → metric → table/figure hash chain.</a:t>
             </a:r>
           </a:p>
           <a:p>
             <a:pPr>
               <a:spcAft>
-                <a:spcPts val="1400"/>
+                <a:spcPts val="1000"/>
               </a:spcAft>
-              <a:defRPr sz="2200"/>
+              <a:defRPr sz="2300"/>
             </a:pPr>
             <a:r>
-              <a:t>Independent fixture verification was performed by the agent, not a peer.</a:t>
+              <a:t>Actual terminal demo and source-linked fallback; owner authorization and AI actions are recorded.</a:t>
             </a:r>
           </a:p>
         </p:txBody>
@@ -4683,7 +4686,7 @@
               <a:defRPr sz="1000"/>
             </a:pPr>
             <a:r>
-              <a:t>Review candidate | exact inputs in results/build_provenance.json | human sign-off pending</a:t>
+              <a:t>Exact inputs in results/build_provenance.json | owner-authorized execution | human activities separately recorded</a:t>
             </a:r>
           </a:p>
         </p:txBody>
@@ -4732,7 +4735,7 @@
               <a:defRPr sz="3000"/>
             </a:pPr>
             <a:r>
-              <a:t>References and artifact entry points</a:t>
+              <a:t>Limits and defensible conclusions</a:t>
             </a:r>
           </a:p>
         </p:txBody>
@@ -4745,7 +4748,7 @@
         </p:nvSpPr>
         <p:spPr>
           <a:xfrm>
-            <a:off x="640080" y="1371600"/>
+            <a:off x="640080" y="1325880"/>
             <a:ext cx="10881360" cy="4846320"/>
           </a:xfrm>
           <a:prstGeom prst="rect">
@@ -4761,45 +4764,45 @@
           <a:p>
             <a:pPr>
               <a:spcAft>
-                <a:spcPts val="1400"/>
+                <a:spcPts val="1000"/>
               </a:spcAft>
-              <a:defRPr sz="2200"/>
+              <a:defRPr sz="2300"/>
             </a:pPr>
             <a:r>
-              <a:t>StreamingLLM: https://arxiv.org/html/2309.17453v4 ; official code pinned in third_party/streaming-llm.</a:t>
+              <a:t>Ten fixed books and one historically exposed smoke book; CI does not establish all-PG19 generality.</a:t>
             </a:r>
           </a:p>
           <a:p>
             <a:pPr>
               <a:spcAft>
-                <a:spcPts val="1400"/>
+                <a:spcPts val="1000"/>
               </a:spcAft>
-              <a:defRPr sz="2200"/>
+              <a:defRPr sz="2300"/>
             </a:pPr>
             <a:r>
-              <a:t>Model: pinned EleutherAI/pythia-2.8b revision and Apache-2.0 model card.</a:t>
+              <a:t>Independent resets, 16K streams and MIG hardware limit direct comparisons with the paper.</a:t>
             </a:r>
           </a:p>
           <a:p>
             <a:pPr>
               <a:spcAft>
-                <a:spcPts val="1400"/>
+                <a:spcPts val="1000"/>
               </a:spcAft>
-              <a:defRPr sz="2200"/>
+              <a:defRPr sz="2300"/>
             </a:pPr>
             <a:r>
-              <a:t>PG19: DeepMind official processed GCS texts and pinned split lists.</a:t>
+              <a:t>No million-token, training or speedup claim. Runtime is measured with unlocked clocks.</a:t>
             </a:r>
           </a:p>
           <a:p>
             <a:pPr>
               <a:spcAft>
-                <a:spcPts val="1400"/>
+                <a:spcPts val="1000"/>
               </a:spcAft>
-              <a:defRPr sz="2200"/>
+              <a:defRPr sz="2300"/>
             </a:pPr>
             <a:r>
-              <a:t>Rebuild: python scripts/build_results.py --manifest results/final_input_manifest.json ; python scripts/build_deliverables.py.</a:t>
+              <a:t>Scientific/engineering evidence is complete only when validated. Peer review, real contributions and individual defense remain human facts.</a:t>
             </a:r>
           </a:p>
         </p:txBody>
@@ -4830,7 +4833,7 @@
               <a:defRPr sz="1000"/>
             </a:pPr>
             <a:r>
-              <a:t>Review candidate | exact inputs in results/build_provenance.json | human sign-off pending</a:t>
+              <a:t>Exact inputs in results/build_provenance.json | owner-authorized execution | human activities separately recorded</a:t>
             </a:r>
           </a:p>
         </p:txBody>
@@ -4879,7 +4882,7 @@
               <a:defRPr sz="3000"/>
             </a:pPr>
             <a:r>
-              <a:t>Claim and current evidence</a:t>
+              <a:t>Why positions matter</a:t>
             </a:r>
           </a:p>
         </p:txBody>
@@ -4892,7 +4895,7 @@
         </p:nvSpPr>
         <p:spPr>
           <a:xfrm>
-            <a:off x="640080" y="1371600"/>
+            <a:off x="640080" y="1325880"/>
             <a:ext cx="10881360" cy="4846320"/>
           </a:xfrm>
           <a:prstGeom prst="rect">
@@ -4908,34 +4911,45 @@
           <a:p>
             <a:pPr>
               <a:spcAft>
-                <a:spcPts val="1400"/>
+                <a:spcPts val="1000"/>
               </a:spcAft>
-              <a:defRPr sz="2200"/>
+              <a:defRPr sz="2300"/>
             </a:pPr>
             <a:r>
-              <a:t>We study whether retaining four initial attention-sink tokens improves equal-book post-overflow NLL over window attention with a 1024-position retained KV budget.</a:t>
+              <a:t>Retain initial sinks and recent K/V within a fixed budget.</a:t>
             </a:r>
           </a:p>
           <a:p>
             <a:pPr>
               <a:spcAft>
-                <a:spcPts val="1400"/>
+                <a:spcPts val="1000"/>
               </a:spcAft>
-              <a:defRPr sz="2200"/>
+              <a:defRPr sz="2300"/>
             </a:pPr>
             <a:r>
-              <a:t>The current artifact is a review candidate: scientific reproduction, validation pilots, method selection and human freeze approval are pending.</a:t>
+              <a:t>Cache raw K before RoPE; rotate every layer using positions continuous within the current cache.</a:t>
             </a:r>
           </a:p>
           <a:p>
             <a:pPr>
               <a:spcAft>
-                <a:spcPts val="1400"/>
+                <a:spcPts val="1000"/>
               </a:spcAft>
-              <a:defRPr sz="2200"/>
+              <a:defRPr sz="2300"/>
             </a:pPr>
             <a:r>
-              <a:t>Diagnostics are measured; no final claim verdict is asserted.</a:t>
+              <a:t>A current-token position ID alone cannot verify historical query-key distances.</a:t>
+            </a:r>
+          </a:p>
+          <a:p>
+            <a:pPr>
+              <a:spcAft>
+                <a:spcPts val="1000"/>
+              </a:spcAft>
+              <a:defRPr sz="2300"/>
+            </a:pPr>
+            <a:r>
+              <a:t>The position repair restores the baseline; H1/H2 are separate improvement hypotheses.</a:t>
             </a:r>
           </a:p>
         </p:txBody>
@@ -4966,7 +4980,7 @@
               <a:defRPr sz="1000"/>
             </a:pPr>
             <a:r>
-              <a:t>Review candidate | exact inputs in results/build_provenance.json | human sign-off pending</a:t>
+              <a:t>Exact inputs in results/build_provenance.json | owner-authorized execution | human activities separately recorded</a:t>
             </a:r>
           </a:p>
         </p:txBody>
@@ -5015,7 +5029,7 @@
               <a:defRPr sz="3000"/>
             </a:pPr>
             <a:r>
-              <a:t>Mechanism and position correction</a:t>
+              <a:t>Frozen inputs and scoring</a:t>
             </a:r>
           </a:p>
         </p:txBody>
@@ -5028,7 +5042,7 @@
         </p:nvSpPr>
         <p:spPr>
           <a:xfrm>
-            <a:off x="640080" y="1371600"/>
+            <a:off x="640080" y="1325880"/>
             <a:ext cx="10881360" cy="4846320"/>
           </a:xfrm>
           <a:prstGeom prst="rect">
@@ -5044,45 +5058,45 @@
           <a:p>
             <a:pPr>
               <a:spcAft>
-                <a:spcPts val="1400"/>
+                <a:spcPts val="1000"/>
               </a:spcAft>
-              <a:defRPr sz="2200"/>
+              <a:defRPr sz="2300"/>
             </a:pPr>
             <a:r>
-              <a:t>StreamingLLM retains initial sinks and recent K/V.</a:t>
+              <a:t>Pinned Pythia-2.8B; original ten PG19 test books; per-book cache reset; cap 16,384.</a:t>
             </a:r>
           </a:p>
           <a:p>
             <a:pPr>
               <a:spcAft>
-                <a:spcPts val="1400"/>
+                <a:spcPts val="1000"/>
               </a:spcAft>
-              <a:defRPr sz="2200"/>
+              <a:defRPr sz="2300"/>
             </a:pPr>
             <a:r>
-              <a:t>With GPT-NeoX RoPE, raw keys must be cached before rotation and receive positions continuous within the current cache on each forward.</a:t>
+              <a:t>Input x[i] predicts x[i+1]; evict after forward. Score steps ≥1,025, first target x[1,026].</a:t>
             </a:r>
           </a:p>
           <a:p>
             <a:pPr>
               <a:spcAft>
-                <a:spcPts val="1400"/>
+                <a:spcPts val="1000"/>
               </a:spcAft>
-              <a:defRPr sz="2200"/>
+              <a:defRPr sz="2300"/>
             </a:pPr>
             <a:r>
-              <a:t>Matching only the new token's position ID cannot establish correct query-key distances.</a:t>
+              <a:t>Retain ≤1,024 positions; forward may see 1,025. Total 144,337 scored positions per arm/seed.</a:t>
             </a:r>
           </a:p>
           <a:p>
             <a:pPr>
               <a:spcAft>
-                <a:spcPts val="1400"/>
+                <a:spcPts val="1000"/>
               </a:spcAft>
-              <a:defRPr sz="2200"/>
+              <a:defRPr sz="2300"/>
             </a:pPr>
             <a:r>
-              <a:t>The pinned official patch is enabled on every layer of both arms.</a:t>
+              <a:t>Equal-book paired NLL is primary; pooled token PPL is secondary.</a:t>
             </a:r>
           </a:p>
         </p:txBody>
@@ -5113,7 +5127,7 @@
               <a:defRPr sz="1000"/>
             </a:pPr>
             <a:r>
-              <a:t>Review candidate | exact inputs in results/build_provenance.json | human sign-off pending</a:t>
+              <a:t>Exact inputs in results/build_provenance.json | owner-authorized execution | human activities separately recorded</a:t>
             </a:r>
           </a:p>
         </p:txBody>
@@ -5162,7 +5176,7 @@
               <a:defRPr sz="3000"/>
             </a:pPr>
             <a:r>
-              <a:t>Fixed data and scoring</a:t>
+              <a:t>Independent correctness evidence</a:t>
             </a:r>
           </a:p>
         </p:txBody>
@@ -5175,7 +5189,7 @@
         </p:nvSpPr>
         <p:spPr>
           <a:xfrm>
-            <a:off x="640080" y="1371600"/>
+            <a:off x="640080" y="1325880"/>
             <a:ext cx="10881360" cy="4846320"/>
           </a:xfrm>
           <a:prstGeom prst="rect">
@@ -5191,45 +5205,45 @@
           <a:p>
             <a:pPr>
               <a:spcAft>
-                <a:spcPts val="1400"/>
+                <a:spcPts val="1000"/>
               </a:spcAft>
-              <a:defRPr sz="2200"/>
+              <a:defRPr sz="2300"/>
             </a:pPr>
             <a:r>
-              <a:t>Pinned Pythia-2.8B and tokenizer; original ten PG19 test books, independent book resets.</a:t>
+              <a:t>Known-probability scorer fixtures and unequal-book-length aggregation counterexamples.</a:t>
             </a:r>
           </a:p>
           <a:p>
             <a:pPr>
               <a:spcAft>
-                <a:spcPts val="1400"/>
+                <a:spcPts val="1000"/>
               </a:spcAft>
-              <a:defRPr sz="2200"/>
+              <a:defRPr sz="2300"/>
             </a:pPr>
             <a:r>
-              <a:t>Input cap 16384; book 12204 has 7141 tokens.</a:t>
+              <a:t>Three-layer tiny-model oracle: every-layer trigonometric RoPE, raw-K/V, attention and final logits; full-checkpoint integration separately.</a:t>
             </a:r>
           </a:p>
           <a:p>
             <a:pPr>
               <a:spcAft>
-                <a:spcPts val="1400"/>
+                <a:spcPts val="1000"/>
               </a:spcAft>
-              <a:defRPr sz="2200"/>
+              <a:defRPr sz="2300"/>
             </a:pPr>
             <a:r>
-              <a:t>Total inputs 154597, predictions 154587, scored positions 144337 per arm/seed.</a:t>
+              <a:t>Strict book/token/mask/source/device contracts; missing, duplicate and nonfinite outputs fail.</a:t>
             </a:r>
           </a:p>
           <a:p>
             <a:pPr>
               <a:spcAft>
-                <a:spcPts val="1400"/>
+                <a:spcPts val="1000"/>
               </a:spcAft>
-              <a:defRPr sz="2200"/>
+              <a:defRPr sz="2300"/>
             </a:pPr>
             <a:r>
-              <a:t>Input x[i] predicts x[i+1]; eviction follows forward.</a:t>
+              <a:t>57 CPU checks and 2 actual H800 GPU precision checks pass; failed attempts remain visible.</a:t>
             </a:r>
           </a:p>
         </p:txBody>
@@ -5260,7 +5274,7 @@
               <a:defRPr sz="1000"/>
             </a:pPr>
             <a:r>
-              <a:t>Review candidate | exact inputs in results/build_provenance.json | human sign-off pending</a:t>
+              <a:t>Exact inputs in results/build_provenance.json | owner-authorized execution | human activities separately recorded</a:t>
             </a:r>
           </a:p>
         </p:txBody>
@@ -5309,7 +5323,7 @@
               <a:defRPr sz="3000"/>
             </a:pPr>
             <a:r>
-              <a:t>Statistics and independent verification</a:t>
+              <a:t>Formal reproduction</a:t>
             </a:r>
           </a:p>
         </p:txBody>
@@ -5322,8 +5336,8 @@
         </p:nvSpPr>
         <p:spPr>
           <a:xfrm>
-            <a:off x="640080" y="1371600"/>
-            <a:ext cx="10881360" cy="4846320"/>
+            <a:off x="640080" y="1325880"/>
+            <a:ext cx="10881360" cy="2286000"/>
           </a:xfrm>
           <a:prstGeom prst="rect">
             <a:avLst/>
@@ -5338,52 +5352,65 @@
           <a:p>
             <a:pPr>
               <a:spcAft>
-                <a:spcPts val="1400"/>
+                <a:spcPts val="1000"/>
               </a:spcAft>
-              <a:defRPr sz="2200"/>
+              <a:defRPr sz="1800"/>
             </a:pPr>
             <a:r>
-              <a:t>Primary estimand: seed-paired per-book NLL deltas averaged within book, then averaged equally over books.</a:t>
+              <a:t>Paired equal-book delta -0.721756 nats/token; 95% CI [-0.759084, -0.685837]. Verdict: supported.</a:t>
             </a:r>
           </a:p>
           <a:p>
             <a:pPr>
               <a:spcAft>
-                <a:spcPts val="1400"/>
+                <a:spcPts val="1000"/>
               </a:spcAft>
-              <a:defRPr sz="2200"/>
+              <a:defRPr sz="1800"/>
             </a:pPr>
             <a:r>
-              <a:t>Percentile 95% CI uses 10000 book-cluster resamples, RNG seed 0.</a:t>
+              <a:t>Macro NLL 3.151635 → 2.429879; secondary micro PPL 23.958 → 11.692.</a:t>
             </a:r>
           </a:p>
           <a:p>
             <a:pPr>
               <a:spcAft>
-                <a:spcPts val="1400"/>
+                <a:spcPts val="1000"/>
               </a:spcAft>
-              <a:defRPr sz="2200"/>
+              <a:defRPr sz="1800"/>
             </a:pPr>
             <a:r>
-              <a:t>Actual model seeds 0, 1, 2 are distinct from bootstrap seeds and never create 30 independent books.</a:t>
-            </a:r>
-          </a:p>
-          <a:p>
-            <a:pPr>
-              <a:spcAft>
-                <a:spcPts val="1400"/>
-              </a:spcAft>
-              <a:defRPr sz="2200"/>
-            </a:pPr>
-            <a:r>
-              <a:t>Micro token NLL/PPL is secondary; exp(macro NLL) is macro-derived PPL.</a:t>
-            </a:r>
-          </a:p>
-        </p:txBody>
-      </p:sp>
-      <p:sp>
-        <p:nvSpPr>
-          <p:cNvPr id="4" name="TextBox 3"/>
+              <a:t>10 books, actual seeds [0, 1, 2]; seeds are averaged within each book before the book bootstrap.</a:t>
+            </a:r>
+          </a:p>
+        </p:txBody>
+      </p:sp>
+      <p:pic>
+        <p:nvPicPr>
+          <p:cNvPr id="4" name="Picture 3" descr="reproduction_per_book_delta.png"/>
+          <p:cNvPicPr>
+            <a:picLocks noChangeAspect="1"/>
+          </p:cNvPicPr>
+          <p:nvPr/>
+        </p:nvPicPr>
+        <p:blipFill>
+          <a:blip r:embed="rId2"/>
+          <a:stretch>
+            <a:fillRect/>
+          </a:stretch>
+        </p:blipFill>
+        <p:spPr>
+          <a:xfrm>
+            <a:off x="3672687" y="3794760"/>
+            <a:ext cx="4846320" cy="2423160"/>
+          </a:xfrm>
+          <a:prstGeom prst="rect">
+            <a:avLst/>
+          </a:prstGeom>
+        </p:spPr>
+      </p:pic>
+      <p:sp>
+        <p:nvSpPr>
+          <p:cNvPr id="5" name="TextBox 4"/>
           <p:cNvSpPr txBox="1"/>
           <p:nvPr/>
         </p:nvSpPr>
@@ -5407,7 +5434,7 @@
               <a:defRPr sz="1000"/>
             </a:pPr>
             <a:r>
-              <a:t>Review candidate | exact inputs in results/build_provenance.json | human sign-off pending</a:t>
+              <a:t>Exact inputs in results/build_provenance.json | owner-authorized execution | human activities separately recorded</a:t>
             </a:r>
           </a:p>
         </p:txBody>
@@ -5456,7 +5483,7 @@
               <a:defRPr sz="3000"/>
             </a:pPr>
             <a:r>
-              <a:t>Measured 2 by 2 diagnostic</a:t>
+              <a:t>What the old smoke concealed</a:t>
             </a:r>
           </a:p>
         </p:txBody>
@@ -5469,8 +5496,8 @@
         </p:nvSpPr>
         <p:spPr>
           <a:xfrm>
-            <a:off x="640080" y="1371600"/>
-            <a:ext cx="10881360" cy="4846320"/>
+            <a:off x="640080" y="1325880"/>
+            <a:ext cx="10881360" cy="2286000"/>
           </a:xfrm>
           <a:prstGeom prst="rect">
             <a:avLst/>
@@ -5485,52 +5512,65 @@
           <a:p>
             <a:pPr>
               <a:spcAft>
-                <a:spcPts val="1400"/>
+                <a:spcPts val="1000"/>
               </a:spcAft>
-              <a:defRPr sz="2200"/>
+              <a:defRPr sz="1800"/>
             </a:pPr>
             <a:r>
-              <a:t>D-W0-20261008: NLL 5.450578; D-S0-20261008: NLL 5.292458; D-W1-20261008: NLL 3.051129; D-S1-20261008: NLL 2.223681.</a:t>
+              <a:t>Legacy: window 5.450578, sinks 5.292458; local delta −0.158119.</a:t>
             </a:r>
           </a:p>
           <a:p>
             <a:pPr>
               <a:spcAft>
-                <a:spcPts val="1400"/>
+                <a:spcPts val="1000"/>
               </a:spcAft>
-              <a:defRPr sz="2200"/>
+              <a:defRPr sz="1800"/>
             </a:pPr>
             <a:r>
-              <a:t>Each run uses one historically exposed smoke book, 4096 inputs and 3070 scored positions.</a:t>
+              <a:t>Corrected positions: window 3.051129, sinks 2.223681; local delta −0.827448.</a:t>
             </a:r>
           </a:p>
           <a:p>
             <a:pPr>
               <a:spcAft>
-                <a:spcPts val="1400"/>
+                <a:spcPts val="1000"/>
               </a:spcAft>
-              <a:defRPr sz="2200"/>
+              <a:defRPr sz="1800"/>
             </a:pPr>
             <a:r>
-              <a:t>Faithful positions change both absolute losses and the method gap.</a:t>
-            </a:r>
-          </a:p>
-          <a:p>
-            <a:pPr>
-              <a:spcAft>
-                <a:spcPts val="1400"/>
-              </a:spcAft>
-              <a:defRPr sz="2200"/>
-            </a:pPr>
-            <a:r>
-              <a:t>Actual retained K+V bytes plateau480MiB in legacy and320MiB in faithful positions, matching between methods within each position policy.</a:t>
-            </a:r>
-          </a:p>
-        </p:txBody>
-      </p:sp>
-      <p:sp>
-        <p:nvSpPr>
-          <p:cNvPr id="4" name="TextBox 3"/>
+              <a:t>One exposed book / 3,070 scored positions: mechanism diagnosis, separate from the formal verdict.</a:t>
+            </a:r>
+          </a:p>
+        </p:txBody>
+      </p:sp>
+      <p:pic>
+        <p:nvPicPr>
+          <p:cNvPr id="4" name="Picture 3" descr="diagnostic_nll_vs_position.png"/>
+          <p:cNvPicPr>
+            <a:picLocks noChangeAspect="1"/>
+          </p:cNvPicPr>
+          <p:nvPr/>
+        </p:nvPicPr>
+        <p:blipFill>
+          <a:blip r:embed="rId2"/>
+          <a:stretch>
+            <a:fillRect/>
+          </a:stretch>
+        </p:blipFill>
+        <p:spPr>
+          <a:xfrm>
+            <a:off x="3672687" y="3794760"/>
+            <a:ext cx="4846320" cy="2423160"/>
+          </a:xfrm>
+          <a:prstGeom prst="rect">
+            <a:avLst/>
+          </a:prstGeom>
+        </p:spPr>
+      </p:pic>
+      <p:sp>
+        <p:nvSpPr>
+          <p:cNvPr id="5" name="TextBox 4"/>
           <p:cNvSpPr txBox="1"/>
           <p:nvPr/>
         </p:nvSpPr>
@@ -5554,7 +5594,7 @@
               <a:defRPr sz="1000"/>
             </a:pPr>
             <a:r>
-              <a:t>Review candidate | exact inputs in results/build_provenance.json | human sign-off pending</a:t>
+              <a:t>Exact inputs in results/build_provenance.json | owner-authorized execution | human activities separately recorded</a:t>
             </a:r>
           </a:p>
         </p:txBody>
@@ -5603,7 +5643,7 @@
               <a:defRPr sz="3000"/>
             </a:pPr>
             <a:r>
-              <a:t>Reproduction status and paper comparison</a:t>
+              <a:t>Three falsifiable hypotheses</a:t>
             </a:r>
           </a:p>
         </p:txBody>
@@ -5616,7 +5656,7 @@
         </p:nvSpPr>
         <p:spPr>
           <a:xfrm>
-            <a:off x="640080" y="1371600"/>
+            <a:off x="640080" y="1325880"/>
             <a:ext cx="10881360" cy="4846320"/>
           </a:xfrm>
           <a:prstGeom prst="rect">
@@ -5632,45 +5672,45 @@
           <a:p>
             <a:pPr>
               <a:spcAft>
-                <a:spcPts val="1400"/>
+                <a:spcPts val="1000"/>
               </a:spcAft>
-              <a:defRPr sz="2200"/>
+              <a:defRPr sz="2300"/>
             </a:pPr>
             <a:r>
-              <a:t>Formal six-job reproduction matrix is implemented but not run: protocol approval and a feasible approved budget path are missing.</a:t>
+              <a:t>H1: freeze the smallest k in {1,2,4,8} covering 90% of first-eight causal prefix attention mass.</a:t>
             </a:r>
           </a:p>
           <a:p>
             <a:pPr>
               <a:spcAft>
-                <a:spcPts val="1400"/>
+                <a:spcPts val="1000"/>
               </a:spcAft>
-              <a:defRPr sz="2200"/>
+              <a:defRPr sz="2300"/>
             </a:pPr>
             <a:r>
-              <a:t>Paper arXiv v4 section 3.2 defines cache-relative positions; Figure 3 gives short-stream language-modeling comparisons, Figure 5 gives super-long-stream results, and Figure 4 illustrates the cache.</a:t>
+              <a:t>H2: keep position 0 plus three causal attention-ranked anchors among positions 1–63.</a:t>
             </a:r>
           </a:p>
           <a:p>
             <a:pPr>
               <a:spcAft>
-                <a:spcPts val="1400"/>
+                <a:spcPts val="1000"/>
               </a:spcAft>
-              <a:defRPr sz="2200"/>
+              <a:defRPr sz="2300"/>
             </a:pPr>
             <a:r>
-              <a:t>The paper concatenates books; our independent-book reset and post-overflow aggregation are explicit deviations.</a:t>
+              <a:t>H3: optional preallocated rolling KV, conditional on profiler evidence; not implemented.</a:t>
             </a:r>
           </a:p>
           <a:p>
             <a:pPr>
               <a:spcAft>
-                <a:spcPts val="1400"/>
+                <a:spcPts val="1000"/>
               </a:spcAft>
-              <a:defRPr sz="2200"/>
+              <a:defRPr sz="2300"/>
             </a:pPr>
             <a:r>
-              <a:t>No incompatible absolute-PPL target or paper speedup is claimed.</a:t>
+              <a:t>No test tuning. Two validation pilots use three frozen books, 8,192-token caps and seeds 0/1/2.</a:t>
             </a:r>
           </a:p>
         </p:txBody>
@@ -5701,7 +5741,7 @@
               <a:defRPr sz="1000"/>
             </a:pPr>
             <a:r>
-              <a:t>Review candidate | exact inputs in results/build_provenance.json | human sign-off pending</a:t>
+              <a:t>Exact inputs in results/build_provenance.json | owner-authorized execution | human activities separately recorded</a:t>
             </a:r>
           </a:p>
         </p:txBody>
@@ -5750,7 +5790,7 @@
               <a:defRPr sz="3000"/>
             </a:pPr>
             <a:r>
-              <a:t>Three improvement hypotheses and two pilots</a:t>
+              <a:t>Pilots and frozen selection</a:t>
             </a:r>
           </a:p>
         </p:txBody>
@@ -5763,7 +5803,7 @@
         </p:nvSpPr>
         <p:spPr>
           <a:xfrm>
-            <a:off x="640080" y="1371600"/>
+            <a:off x="640080" y="1325880"/>
             <a:ext cx="10881360" cy="4846320"/>
           </a:xfrm>
           <a:prstGeom prst="rect">
@@ -5779,45 +5819,12 @@
           <a:p>
             <a:pPr>
               <a:spcAft>
-                <a:spcPts val="1400"/>
+                <a:spcPts val="1000"/>
               </a:spcAft>
-              <a:defRPr sz="2200"/>
+              <a:defRPr sz="2300"/>
             </a:pPr>
             <a:r>
-              <a:t>H1 selects the smallest k in {1,2,4,8} covering 90% of first-eight attention mass from queries 64 through 511, then freezes k within the book.</a:t>
-            </a:r>
-          </a:p>
-          <a:p>
-            <a:pPr>
-              <a:spcAft>
-                <a:spcPts val="1400"/>
-              </a:spcAft>
-              <a:defRPr sz="2200"/>
-            </a:pPr>
-            <a:r>
-              <a:t>H2 protects position 0 and chooses the three highest-mass positions 1 through 63, breaks ties earlier, preserves chronological order and deduplicates recent K/V.</a:t>
-            </a:r>
-          </a:p>
-          <a:p>
-            <a:pPr>
-              <a:spcAft>
-                <a:spcPts val="1400"/>
-              </a:spcAft>
-              <a:defRPr sz="2200"/>
-            </a:pPr>
-            <a:r>
-              <a:t>Both use only causal prefix attention and a fixed 1024 retained budget.</a:t>
-            </a:r>
-          </a:p>
-          <a:p>
-            <a:pPr>
-              <a:spcAft>
-                <a:spcPts val="1400"/>
-              </a:spcAft>
-              <a:defRPr sz="2200"/>
-            </a:pPr>
-            <a:r>
-              <a:t>H3 is optional preallocated rolling-KV systems work, motivated only if a profiler shows material allocation cost; it is not implemented.</a:t>
+              <a:t>Recorded selection: None. Lower negative mean delta wins subject to runtime/memory ≤1.10x; H1 is the negative-result fallback.</a:t>
             </a:r>
           </a:p>
         </p:txBody>
@@ -5848,7 +5855,7 @@
               <a:defRPr sz="1000"/>
             </a:pPr>
             <a:r>
-              <a:t>Review candidate | exact inputs in results/build_provenance.json | human sign-off pending</a:t>
+              <a:t>Exact inputs in results/build_provenance.json | owner-authorized execution | human activities separately recorded</a:t>
             </a:r>
           </a:p>
         </p:txBody>
@@ -5897,7 +5904,7 @@
               <a:defRPr sz="3000"/>
             </a:pPr>
             <a:r>
-              <a:t>Selection, full evaluation and controls</a:t>
+              <a:t>Full selected-method evaluation</a:t>
             </a:r>
           </a:p>
         </p:txBody>
@@ -5910,7 +5917,7 @@
         </p:nvSpPr>
         <p:spPr>
           <a:xfrm>
-            <a:off x="640080" y="1371600"/>
+            <a:off x="640080" y="1325880"/>
             <a:ext cx="10881360" cy="4846320"/>
           </a:xfrm>
           <a:prstGeom prst="rect">
@@ -5926,45 +5933,23 @@
           <a:p>
             <a:pPr>
               <a:spcAft>
-                <a:spcPts val="1400"/>
+                <a:spcPts val="1000"/>
               </a:spcAft>
-              <a:defRPr sz="2200"/>
+              <a:defRPr sz="2300"/>
             </a:pPr>
             <a:r>
-              <a:t>Compare valid H1/H2 pilots against faithful fixed-four StreamingLLM.</a:t>
+              <a:t>Full evaluation follows the frozen pilot rule.</a:t>
             </a:r>
           </a:p>
           <a:p>
             <a:pPr>
               <a:spcAft>
-                <a:spcPts val="1400"/>
+                <a:spcPts val="1000"/>
               </a:spcAft>
-              <a:defRPr sz="2200"/>
+              <a:defRPr sz="2300"/>
             </a:pPr>
             <a:r>
-              <a:t>Acceptable runtime and extra peak-memory ratios are proposed at 1.10.</a:t>
-            </a:r>
-          </a:p>
-          <a:p>
-            <a:pPr>
-              <a:spcAft>
-                <a:spcPts val="1400"/>
-              </a:spcAft>
-              <a:defRPr sz="2200"/>
-            </a:pPr>
-            <a:r>
-              <a:t>Prefer lower paired NLL at acceptable cost; if neither improves, nominate simpler H1 for a full negative-result evaluation without additional searches.</a:t>
-            </a:r>
-          </a:p>
-          <a:p>
-            <a:pPr>
-              <a:spcAft>
-                <a:spcPts val="1400"/>
-              </a:spcAft>
-              <a:defRPr sz="2200"/>
-            </a:pPr>
-            <a:r>
-              <a:t>A real team decision must confirm selection.</a:t>
+              <a:t>No final numerical verdict is assigned before all registered outputs validate.</a:t>
             </a:r>
           </a:p>
         </p:txBody>
@@ -5995,7 +5980,7 @@
               <a:defRPr sz="1000"/>
             </a:pPr>
             <a:r>
-              <a:t>Review candidate | exact inputs in results/build_provenance.json | human sign-off pending</a:t>
+              <a:t>Exact inputs in results/build_provenance.json | owner-authorized execution | human activities separately recorded</a:t>
             </a:r>
           </a:p>
         </p:txBody>

</xml_diff>

<commit_message>
experiment: complete both pilots and freeze measured H2 selection
</commit_message>
<xml_diff>
--- a/presentation/defense_draft.pptx
+++ b/presentation/defense_draft.pptx
@@ -583,7 +583,7 @@
           <a:lstStyle/>
           <a:p>
             <a:r>
-              <a:t>Registered development pilots are still running. Selection follows the frozen lower-mean-NLL/cost rule with runtime and peak-memory ratios at most 1.10. If neither qualifies, simpler H1 is evaluated as the preregistered negative-result fallback. The owner delegated this rule; no parameter search or test selection is added. Recorded selection: None. Full comparison against fixed-four StreamingLLM: Complete paired results are still pending; no verdict is assigned. Selected controls: Selected controls are pending complete raw outputs. Forced-prefix identity is independently tested; H1 has calibration-only/fixed-k controls, H2 forced-prefix/random-anchor controls. Controls use the development set and cannot be treated as full-test effects. Only the selected family's controls are required and executed. Full-test per-book cases remain pending. Per-book frozen anchors/k and calibration intervals are in tables/improvement_book_selections.csv.</a:t>
+              <a:t>h1_adaptive_sink: development delta -0.005345, 95% CI [-0.016612, 0.000460], runtime ratio 1.0026, peak-memory ratio 1.0000, acceptable cost True; h2_sink_selection: development delta -0.008053, 95% CI [-0.016347, -0.001836], runtime ratio 1.0084, peak-memory ratio 1.0000, acceptable cost True Selection follows the frozen lower-mean-NLL/cost rule with runtime and peak-memory ratios at most 1.10. If neither qualifies, simpler H1 is evaluated as the preregistered negative-result fallback. The owner delegated this rule; no parameter search or test selection is added. Recorded selection: h2_sink_selection. Full comparison against fixed-four StreamingLLM: Complete paired results are still pending; no verdict is assigned. Selected controls: Selected controls are pending complete raw outputs. Forced-prefix identity is independently tested; H1 has calibration-only/fixed-k controls, H2 forced-prefix/random-anchor controls. Controls use the development set and cannot be treated as full-test effects. Only the selected family's controls are required and executed. Full-test per-book cases remain pending. Per-book frozen anchors/k and calibration intervals are in tables/improvement_book_selections.csv.</a:t>
             </a:r>
           </a:p>
           <a:p/>
@@ -659,7 +659,7 @@
           <a:lstStyle/>
           <a:p>
             <a:r>
-              <a:t>Current spent/reserved charge is 14.689379 device-instance hours, with a conservative 0.27h historical reserve. Full-GPU and MIG instance wall-hours are not normalized billing or currency cost. The user authorized unrestricted resources; 20h is no longer an execution limit. Three existing idle H800 MIG instances run seed workers concurrently, preserving another project on GPU0. Each attempt records selected UUID/parent, 30-SM class, driver, clock/power snapshot, source/config/data hashes, status, per-book recovery and actual whole-process time. Runtime comparisons use the matched MIG class; clocks are not locked. Calibration intervals include forward and attention collection, measured as host wall time; they are not isolated kernel costs. Incremental cost is assessed through whole-run ratios and controls. Pinned Python 3.10.12 / torch 2.14.0+cu130 / Transformers 4.33.0 and NVML bindings restore through setup. GPU1 instances are unaffected by GPU0's nightly cron.</a:t>
+              <a:t>Current spent/reserved charge is 26.697345 device-instance hours, with a conservative 0.27h historical reserve. Full-GPU and MIG instance wall-hours are not normalized billing or currency cost. The user authorized unrestricted resources; 20h is no longer an execution limit. Three existing idle H800 MIG instances run seed workers concurrently, preserving another project on GPU0. Each attempt records selected UUID/parent, 30-SM class, driver, clock/power snapshot, source/config/data hashes, status, per-book recovery and registered-run wall time. The timer begins at run-directory creation and ends at finish(), includes model loading/inference/failure intervals, and excludes preflight/startup, the initial Git snapshot and post-finish checksum/exit tails. These are the same stored runtime_seconds used by the frozen cost rule; no cost field or threshold is changed. Runtime comparisons use the matched MIG class; clocks are not locked. Calibration intervals include necessary prefix forward passes and attention collection, measured as host wall time; they are not isolated extra kernel costs and are not added again to the registered-run charge. Incremental cost is assessed through registered-run ratios and controls. Pinned Python 3.10.12 / torch 2.14.0+cu130 / Transformers 4.33.0 and NVML bindings restore through setup. GPU1 instances are unaffected by GPU0's nightly cron.</a:t>
             </a:r>
           </a:p>
           <a:p/>
@@ -1225,7 +1225,7 @@
           <a:lstStyle/>
           <a:p>
             <a:r>
-              <a:t>Registered development pilots are still running. Selection follows the frozen lower-mean-NLL/cost rule with runtime and peak-memory ratios at most 1.10. If neither qualifies, simpler H1 is evaluated as the preregistered negative-result fallback. The owner delegated this rule; no parameter search or test selection is added. Recorded selection: None. Full comparison against fixed-four StreamingLLM: Complete paired results are still pending; no verdict is assigned. Selected controls: Selected controls are pending complete raw outputs. Forced-prefix identity is independently tested; H1 has calibration-only/fixed-k controls, H2 forced-prefix/random-anchor controls. Controls use the development set and cannot be treated as full-test effects. Only the selected family's controls are required and executed. Full-test per-book cases remain pending. Per-book frozen anchors/k and calibration intervals are in tables/improvement_book_selections.csv.</a:t>
+              <a:t>h1_adaptive_sink: development delta -0.005345, 95% CI [-0.016612, 0.000460], runtime ratio 1.0026, peak-memory ratio 1.0000, acceptable cost True; h2_sink_selection: development delta -0.008053, 95% CI [-0.016347, -0.001836], runtime ratio 1.0084, peak-memory ratio 1.0000, acceptable cost True Selection follows the frozen lower-mean-NLL/cost rule with runtime and peak-memory ratios at most 1.10. If neither qualifies, simpler H1 is evaluated as the preregistered negative-result fallback. The owner delegated this rule; no parameter search or test selection is added. Recorded selection: h2_sink_selection. Full comparison against fixed-four StreamingLLM: Complete paired results are still pending; no verdict is assigned. Selected controls: Selected controls are pending complete raw outputs. Forced-prefix identity is independently tested; H1 has calibration-only/fixed-k controls, H2 forced-prefix/random-anchor controls. Controls use the development set and cannot be treated as full-test effects. Only the selected family's controls are required and executed. Full-test per-book cases remain pending. Per-book frozen anchors/k and calibration intervals are in tables/improvement_book_selections.csv.</a:t>
             </a:r>
           </a:p>
         </p:txBody>
@@ -1295,7 +1295,7 @@
           <a:lstStyle/>
           <a:p>
             <a:r>
-              <a:t>Registered development pilots are still running. Selection follows the frozen lower-mean-NLL/cost rule with runtime and peak-memory ratios at most 1.10. If neither qualifies, simpler H1 is evaluated as the preregistered negative-result fallback. The owner delegated this rule; no parameter search or test selection is added. Recorded selection: None. Full comparison against fixed-four StreamingLLM: Complete paired results are still pending; no verdict is assigned. Selected controls: Selected controls are pending complete raw outputs. Forced-prefix identity is independently tested; H1 has calibration-only/fixed-k controls, H2 forced-prefix/random-anchor controls. Controls use the development set and cannot be treated as full-test effects. Only the selected family's controls are required and executed. Full-test per-book cases remain pending. Per-book frozen anchors/k and calibration intervals are in tables/improvement_book_selections.csv.</a:t>
+              <a:t>h1_adaptive_sink: development delta -0.005345, 95% CI [-0.016612, 0.000460], runtime ratio 1.0026, peak-memory ratio 1.0000, acceptable cost True; h2_sink_selection: development delta -0.008053, 95% CI [-0.016347, -0.001836], runtime ratio 1.0084, peak-memory ratio 1.0000, acceptable cost True Selection follows the frozen lower-mean-NLL/cost rule with runtime and peak-memory ratios at most 1.10. If neither qualifies, simpler H1 is evaluated as the preregistered negative-result fallback. The owner delegated this rule; no parameter search or test selection is added. Recorded selection: h2_sink_selection. Full comparison against fixed-four StreamingLLM: Complete paired results are still pending; no verdict is assigned. Selected controls: Selected controls are pending complete raw outputs. Forced-prefix identity is independently tested; H1 has calibration-only/fixed-k controls, H2 forced-prefix/random-anchor controls. Controls use the development set and cannot be treated as full-test effects. Only the selected family's controls are required and executed. Full-test per-book cases remain pending. Per-book frozen anchors/k and calibration intervals are in tables/improvement_book_selections.csv.</a:t>
             </a:r>
           </a:p>
         </p:txBody>
@@ -4383,7 +4383,7 @@
               <a:defRPr sz="2300"/>
             </a:pPr>
             <a:r>
-              <a:t>Selected improvement: None; matched H800 MIG 2g.20gb instances.</a:t>
+              <a:t>Selected improvement: h2_sink_selection; matched H800 MIG 2g.20gb instances.</a:t>
             </a:r>
           </a:p>
         </p:txBody>
@@ -5824,7 +5824,29 @@
               <a:defRPr sz="2300"/>
             </a:pPr>
             <a:r>
-              <a:t>Recorded selection: None. Lower negative mean delta wins subject to runtime/memory ≤1.10x; H1 is the negative-result fallback.</a:t>
+              <a:t>h1_adaptive_sink: delta -0.005345; runtime 1.003x; peak memory 1.000x; cost acceptable: True.</a:t>
+            </a:r>
+          </a:p>
+          <a:p>
+            <a:pPr>
+              <a:spcAft>
+                <a:spcPts val="1000"/>
+              </a:spcAft>
+              <a:defRPr sz="2300"/>
+            </a:pPr>
+            <a:r>
+              <a:t>h2_sink_selection: delta -0.008053; runtime 1.008x; peak memory 1.000x; cost acceptable: True.</a:t>
+            </a:r>
+          </a:p>
+          <a:p>
+            <a:pPr>
+              <a:spcAft>
+                <a:spcPts val="1000"/>
+              </a:spcAft>
+              <a:defRPr sz="2300"/>
+            </a:pPr>
+            <a:r>
+              <a:t>Recorded selection: h2_sink_selection. Lower negative mean delta wins subject to runtime/memory ≤1.10x; H1 is the negative-result fallback.</a:t>
             </a:r>
           </a:p>
         </p:txBody>

</xml_diff>

<commit_message>
evidence: seal full H2 test and preserve inconclusive outcome
</commit_message>
<xml_diff>
--- a/presentation/defense_draft.pptx
+++ b/presentation/defense_draft.pptx
@@ -583,7 +583,7 @@
           <a:lstStyle/>
           <a:p>
             <a:r>
-              <a:t>h1_adaptive_sink: development delta -0.005345, 95% CI [-0.016612, 0.000460], runtime ratio 1.0026, peak-memory ratio 1.0000, acceptable cost True; h2_sink_selection: development delta -0.008053, 95% CI [-0.016347, -0.001836], runtime ratio 1.0084, peak-memory ratio 1.0000, acceptable cost True Selection follows the frozen lower-mean-NLL/cost rule with runtime and peak-memory ratios at most 1.10. If neither qualifies, simpler H1 is evaluated as the preregistered negative-result fallback. The owner delegated this rule; no parameter search or test selection is added. Recorded selection: h2_sink_selection. Full comparison against fixed-four StreamingLLM: Complete paired results are still pending; no verdict is assigned. Selected controls: Selected controls are pending complete raw outputs. Forced-prefix identity is independently tested; H1 has calibration-only/fixed-k controls, H2 forced-prefix/random-anchor controls. Controls use the development set and cannot be treated as full-test effects. Only the selected family's controls are required and executed. Full-test per-book cases remain pending. Per-book frozen anchors/k and calibration intervals are in tables/improvement_book_selections.csv.</a:t>
+              <a:t>h1_adaptive_sink: development delta -0.005345, 95% CI [-0.016612, 0.000460], runtime ratio 1.0026, peak-memory ratio 1.0000, acceptable cost True; h2_sink_selection: development delta -0.008053, 95% CI [-0.016347, -0.001836], runtime ratio 1.0084, peak-memory ratio 1.0000, acceptable cost True. Selection follows the frozen lower-mean-NLL/cost rule with runtime and peak-memory ratios at most 1.10. If neither qualifies, simpler H1 is evaluated as the preregistered negative-result fallback. The owner delegated this rule; no parameter search or test selection is added. Recorded selection: h2_sink_selection. Full comparison against fixed-four StreamingLLM: Equal-book candidate-minus-baseline NLL difference 0.000108 nats/token; book-cluster 95% CI [-0.000064, 0.000303]; verdict inconclusive. 10 books, actual model seeds [0, 1, 2]. Baseline macro NLL 2.429879, candidate 2.429987; secondary micro PPL 11.6922 versus 11.6934. Selected controls: Selected controls are pending complete raw outputs. Forced-prefix identity is independently tested; H1 has calibration-only/fixed-k controls, H2 forced-prefix/random-anchor controls. Controls use the development set and cannot be treated as full-test effects. Only the selected family's controls are required and executed. Largest selected-minus-fixed-four book deltas: 22424: 0.000822 nats/token; 10321: 0.000273 nats/token. Maximum per-book delta range across actual seeds: 0. Frozen anchor-set counts across the 30 actual book-seed evaluations: {'[0, 1, 5, 49]': 3, '[0, 1, 29, 57]': 3, '[0, 1, 59, 63]': 3, '[0, 1, 21, 41]': 3, '[0, 1, 53, 57]': 3, '[0, 1, 62, 63]': 3, '[0, 1, 52, 54]': 3, '[0, 1, 24, 42]': 3, '[0, 1, 54, 56]': 3, '[0, 1, 24, 43]': 3}; fallbacks 0. These are descriptive cases on the frozen test set, not a further tuning rule. Per-book frozen anchors/k and calibration intervals are in tables/improvement_book_selections.csv.</a:t>
             </a:r>
           </a:p>
           <a:p/>
@@ -659,7 +659,7 @@
           <a:lstStyle/>
           <a:p>
             <a:r>
-              <a:t>Current spent/reserved charge is 26.697345 device-instance hours, with a conservative 0.27h historical reserve. Full-GPU and MIG instance wall-hours are not normalized billing or currency cost. The user authorized unrestricted resources; 20h is no longer an execution limit. Three existing idle H800 MIG instances run seed workers concurrently, preserving another project on GPU0. Each attempt records selected UUID/parent, 30-SM class, driver, clock/power snapshot, source/config/data hashes, status, per-book recovery and registered-run wall time. The timer begins at run-directory creation and ends at finish(), includes model loading/inference/failure intervals, and excludes preflight/startup, the initial Git snapshot and post-finish checksum/exit tails. These are the same stored runtime_seconds used by the frozen cost rule; no cost field or threshold is changed. Runtime comparisons use the matched MIG class; clocks are not locked. Calibration intervals include necessary prefix forward passes and attention collection, measured as host wall time; they are not isolated extra kernel costs and are not added again to the registered-run charge. Incremental cost is assessed through registered-run ratios and controls. Pinned Python 3.10.12 / torch 2.14.0+cu130 / Transformers 4.33.0 and NVML bindings restore through setup. GPU1 instances are unaffected by GPU0's nightly cron.</a:t>
+              <a:t>Current spent/reserved charge is 23.759499 device-instance hours, with a conservative 0.27h historical reserve. Full-GPU and MIG instance wall-hours are not normalized billing or currency cost. The user authorized unrestricted resources; 20h is no longer an execution limit. Three existing idle H800 MIG instances run seed workers concurrently, preserving another project on GPU0. Each attempt records selected UUID/parent, 30-SM class, driver, clock/power snapshot, source/config/data hashes, status, per-book recovery and registered-run wall time. The timer begins after the launch Git snapshot and run-directory creation and ends at finish(), includes model loading/inference/failure intervals, and excludes preflight/startup, the initial Git snapshot and post-finish checksum/exit tails. These are the same stored runtime_seconds used by the frozen cost rule; no cost field or threshold is changed. Runtime comparisons use the matched MIG class; clocks are not locked. Calibration intervals include necessary prefix forward passes and attention collection, measured as host wall time; they are not isolated extra kernel costs and are not added again to the registered-run charge. Incremental cost is assessed through registered-run ratios and controls. Pinned Python 3.10.12 / torch 2.14.0+cu130 / Transformers 4.33.0 and NVML bindings restore through setup. GPU1 instances are unaffected by GPU0's nightly cron.</a:t>
             </a:r>
           </a:p>
           <a:p/>
@@ -1225,7 +1225,7 @@
           <a:lstStyle/>
           <a:p>
             <a:r>
-              <a:t>h1_adaptive_sink: development delta -0.005345, 95% CI [-0.016612, 0.000460], runtime ratio 1.0026, peak-memory ratio 1.0000, acceptable cost True; h2_sink_selection: development delta -0.008053, 95% CI [-0.016347, -0.001836], runtime ratio 1.0084, peak-memory ratio 1.0000, acceptable cost True Selection follows the frozen lower-mean-NLL/cost rule with runtime and peak-memory ratios at most 1.10. If neither qualifies, simpler H1 is evaluated as the preregistered negative-result fallback. The owner delegated this rule; no parameter search or test selection is added. Recorded selection: h2_sink_selection. Full comparison against fixed-four StreamingLLM: Complete paired results are still pending; no verdict is assigned. Selected controls: Selected controls are pending complete raw outputs. Forced-prefix identity is independently tested; H1 has calibration-only/fixed-k controls, H2 forced-prefix/random-anchor controls. Controls use the development set and cannot be treated as full-test effects. Only the selected family's controls are required and executed. Full-test per-book cases remain pending. Per-book frozen anchors/k and calibration intervals are in tables/improvement_book_selections.csv.</a:t>
+              <a:t>h1_adaptive_sink: development delta -0.005345, 95% CI [-0.016612, 0.000460], runtime ratio 1.0026, peak-memory ratio 1.0000, acceptable cost True; h2_sink_selection: development delta -0.008053, 95% CI [-0.016347, -0.001836], runtime ratio 1.0084, peak-memory ratio 1.0000, acceptable cost True. Selection follows the frozen lower-mean-NLL/cost rule with runtime and peak-memory ratios at most 1.10. If neither qualifies, simpler H1 is evaluated as the preregistered negative-result fallback. The owner delegated this rule; no parameter search or test selection is added. Recorded selection: h2_sink_selection. Full comparison against fixed-four StreamingLLM: Equal-book candidate-minus-baseline NLL difference 0.000108 nats/token; book-cluster 95% CI [-0.000064, 0.000303]; verdict inconclusive. 10 books, actual model seeds [0, 1, 2]. Baseline macro NLL 2.429879, candidate 2.429987; secondary micro PPL 11.6922 versus 11.6934. Selected controls: Selected controls are pending complete raw outputs. Forced-prefix identity is independently tested; H1 has calibration-only/fixed-k controls, H2 forced-prefix/random-anchor controls. Controls use the development set and cannot be treated as full-test effects. Only the selected family's controls are required and executed. Largest selected-minus-fixed-four book deltas: 22424: 0.000822 nats/token; 10321: 0.000273 nats/token. Maximum per-book delta range across actual seeds: 0. Frozen anchor-set counts across the 30 actual book-seed evaluations: {'[0, 1, 5, 49]': 3, '[0, 1, 29, 57]': 3, '[0, 1, 59, 63]': 3, '[0, 1, 21, 41]': 3, '[0, 1, 53, 57]': 3, '[0, 1, 62, 63]': 3, '[0, 1, 52, 54]': 3, '[0, 1, 24, 42]': 3, '[0, 1, 54, 56]': 3, '[0, 1, 24, 43]': 3}; fallbacks 0. These are descriptive cases on the frozen test set, not a further tuning rule. Per-book frozen anchors/k and calibration intervals are in tables/improvement_book_selections.csv.</a:t>
             </a:r>
           </a:p>
         </p:txBody>
@@ -1295,7 +1295,7 @@
           <a:lstStyle/>
           <a:p>
             <a:r>
-              <a:t>h1_adaptive_sink: development delta -0.005345, 95% CI [-0.016612, 0.000460], runtime ratio 1.0026, peak-memory ratio 1.0000, acceptable cost True; h2_sink_selection: development delta -0.008053, 95% CI [-0.016347, -0.001836], runtime ratio 1.0084, peak-memory ratio 1.0000, acceptable cost True Selection follows the frozen lower-mean-NLL/cost rule with runtime and peak-memory ratios at most 1.10. If neither qualifies, simpler H1 is evaluated as the preregistered negative-result fallback. The owner delegated this rule; no parameter search or test selection is added. Recorded selection: h2_sink_selection. Full comparison against fixed-four StreamingLLM: Complete paired results are still pending; no verdict is assigned. Selected controls: Selected controls are pending complete raw outputs. Forced-prefix identity is independently tested; H1 has calibration-only/fixed-k controls, H2 forced-prefix/random-anchor controls. Controls use the development set and cannot be treated as full-test effects. Only the selected family's controls are required and executed. Full-test per-book cases remain pending. Per-book frozen anchors/k and calibration intervals are in tables/improvement_book_selections.csv.</a:t>
+              <a:t>h1_adaptive_sink: development delta -0.005345, 95% CI [-0.016612, 0.000460], runtime ratio 1.0026, peak-memory ratio 1.0000, acceptable cost True; h2_sink_selection: development delta -0.008053, 95% CI [-0.016347, -0.001836], runtime ratio 1.0084, peak-memory ratio 1.0000, acceptable cost True. Selection follows the frozen lower-mean-NLL/cost rule with runtime and peak-memory ratios at most 1.10. If neither qualifies, simpler H1 is evaluated as the preregistered negative-result fallback. The owner delegated this rule; no parameter search or test selection is added. Recorded selection: h2_sink_selection. Full comparison against fixed-four StreamingLLM: Equal-book candidate-minus-baseline NLL difference 0.000108 nats/token; book-cluster 95% CI [-0.000064, 0.000303]; verdict inconclusive. 10 books, actual model seeds [0, 1, 2]. Baseline macro NLL 2.429879, candidate 2.429987; secondary micro PPL 11.6922 versus 11.6934. Selected controls: Selected controls are pending complete raw outputs. Forced-prefix identity is independently tested; H1 has calibration-only/fixed-k controls, H2 forced-prefix/random-anchor controls. Controls use the development set and cannot be treated as full-test effects. Only the selected family's controls are required and executed. Largest selected-minus-fixed-four book deltas: 22424: 0.000822 nats/token; 10321: 0.000273 nats/token. Maximum per-book delta range across actual seeds: 0. Frozen anchor-set counts across the 30 actual book-seed evaluations: {'[0, 1, 5, 49]': 3, '[0, 1, 29, 57]': 3, '[0, 1, 59, 63]': 3, '[0, 1, 21, 41]': 3, '[0, 1, 53, 57]': 3, '[0, 1, 62, 63]': 3, '[0, 1, 52, 54]': 3, '[0, 1, 24, 42]': 3, '[0, 1, 54, 56]': 3, '[0, 1, 24, 43]': 3}; fallbacks 0. These are descriptive cases on the frozen test set, not a further tuning rule. Per-book frozen anchors/k and calibration intervals are in tables/improvement_book_selections.csv.</a:t>
             </a:r>
           </a:p>
         </p:txBody>
@@ -5940,7 +5940,7 @@
         <p:spPr>
           <a:xfrm>
             <a:off x="640080" y="1325880"/>
-            <a:ext cx="10881360" cy="4846320"/>
+            <a:ext cx="10881360" cy="2286000"/>
           </a:xfrm>
           <a:prstGeom prst="rect">
             <a:avLst/>
@@ -5957,10 +5957,10 @@
               <a:spcAft>
                 <a:spcPts val="1000"/>
               </a:spcAft>
-              <a:defRPr sz="2300"/>
+              <a:defRPr sz="1800"/>
             </a:pPr>
             <a:r>
-              <a:t>Full evaluation follows the frozen pilot rule.</a:t>
+              <a:t>Paired equal-book delta 0.000108 nats/token; 95% CI [-0.000064, 0.000303]. Verdict: inconclusive.</a:t>
             </a:r>
           </a:p>
           <a:p>
@@ -5968,17 +5968,52 @@
               <a:spcAft>
                 <a:spcPts val="1000"/>
               </a:spcAft>
-              <a:defRPr sz="2300"/>
+              <a:defRPr sz="1800"/>
             </a:pPr>
             <a:r>
-              <a:t>No final numerical verdict is assigned before all registered outputs validate.</a:t>
-            </a:r>
-          </a:p>
-        </p:txBody>
-      </p:sp>
-      <p:sp>
-        <p:nvSpPr>
-          <p:cNvPr id="4" name="TextBox 3"/>
+              <a:t>Macro NLL 2.429879 → 2.429987; secondary micro PPL 11.692 → 11.693.</a:t>
+            </a:r>
+          </a:p>
+          <a:p>
+            <a:pPr>
+              <a:spcAft>
+                <a:spcPts val="1000"/>
+              </a:spcAft>
+              <a:defRPr sz="1800"/>
+            </a:pPr>
+            <a:r>
+              <a:t>Registered-run runtime 0.996x; peak allocated memory 1.000x.</a:t>
+            </a:r>
+          </a:p>
+        </p:txBody>
+      </p:sp>
+      <p:pic>
+        <p:nvPicPr>
+          <p:cNvPr id="4" name="Picture 3" descr="improvement_quality_cost.png"/>
+          <p:cNvPicPr>
+            <a:picLocks noChangeAspect="1"/>
+          </p:cNvPicPr>
+          <p:nvPr/>
+        </p:nvPicPr>
+        <p:blipFill>
+          <a:blip r:embed="rId2"/>
+          <a:stretch>
+            <a:fillRect/>
+          </a:stretch>
+        </p:blipFill>
+        <p:spPr>
+          <a:xfrm>
+            <a:off x="3066897" y="3794760"/>
+            <a:ext cx="6057900" cy="2423160"/>
+          </a:xfrm>
+          <a:prstGeom prst="rect">
+            <a:avLst/>
+          </a:prstGeom>
+        </p:spPr>
+      </p:pic>
+      <p:sp>
+        <p:nvSpPr>
+          <p:cNvPr id="5" name="TextBox 4"/>
           <p:cNvSpPr txBox="1"/>
           <p:nvPr/>
         </p:nvSpPr>

</xml_diff>